<commit_message>
Update LP slide: request to Ushio-sama from Flight
Co-authored-by: kozonoflight <kozonoflight@users.noreply.github.com>
</commit_message>
<xml_diff>
--- a/Primo分析サービスLP_スケジュールと役割.pptx
+++ b/Primo分析サービスLP_スケジュールと役割.pptx
@@ -3182,8 +3182,8 @@
         </p:nvSpPr>
         <p:spPr>
           <a:xfrm>
-            <a:off x="548640" y="320040"/>
-            <a:ext cx="10972800" cy="640080"/>
+            <a:off x="548640" y="274320"/>
+            <a:ext cx="10972800" cy="594360"/>
           </a:xfrm>
           <a:prstGeom prst="rect">
             <a:avLst/>
@@ -3197,108 +3197,38 @@
           <a:lstStyle/>
           <a:p>
             <a:pPr>
-              <a:defRPr sz="2800" b="1">
+              <a:defRPr sz="2600" b="1">
                 <a:solidFill>
                   <a:srgbClr val="1A3A5C"/>
                 </a:solidFill>
               </a:defRPr>
             </a:pPr>
             <a:r>
-              <a:t>Primo分析サービス LP立ち上げ</a:t>
-            </a:r>
-          </a:p>
-        </p:txBody>
-      </p:sp>
-      <p:sp>
-        <p:nvSpPr>
-          <p:cNvPr id="5" name="TextBox 4"/>
-          <p:cNvSpPr txBox="1"/>
-          <p:nvPr/>
-        </p:nvSpPr>
-        <p:spPr>
-          <a:xfrm>
-            <a:off x="548640" y="868680"/>
-            <a:ext cx="10972800" cy="365760"/>
-          </a:xfrm>
-          <a:prstGeom prst="rect">
-            <a:avLst/>
-          </a:prstGeom>
-          <a:noFill/>
-        </p:spPr>
-        <p:txBody>
-          <a:bodyPr wrap="none">
-            <a:spAutoFit/>
-          </a:bodyPr>
-          <a:lstStyle/>
-          <a:p>
-            <a:pPr>
-              <a:defRPr sz="1400">
-                <a:solidFill>
-                  <a:srgbClr val="555555"/>
-                </a:solidFill>
-              </a:defRPr>
-            </a:pPr>
-            <a:r>
-              <a:t>スケジュール・工程・役割と責任範囲</a:t>
-            </a:r>
-          </a:p>
-        </p:txBody>
-      </p:sp>
-      <p:sp>
-        <p:nvSpPr>
-          <p:cNvPr id="6" name="TextBox 5"/>
-          <p:cNvSpPr txBox="1"/>
-          <p:nvPr/>
-        </p:nvSpPr>
-        <p:spPr>
-          <a:xfrm>
-            <a:off x="548640" y="1371600"/>
-            <a:ext cx="5303520" cy="320040"/>
-          </a:xfrm>
-          <a:prstGeom prst="rect">
-            <a:avLst/>
-          </a:prstGeom>
-          <a:noFill/>
-        </p:spPr>
-        <p:txBody>
-          <a:bodyPr wrap="none">
-            <a:spAutoFit/>
-          </a:bodyPr>
-          <a:lstStyle/>
-          <a:p>
-            <a:pPr>
-              <a:defRPr sz="1600" b="1">
-                <a:solidFill>
-                  <a:srgbClr val="1A3A5C"/>
-                </a:solidFill>
-              </a:defRPr>
-            </a:pPr>
-            <a:r>
-              <a:t>スケジュール・工程</a:t>
-            </a:r>
-          </a:p>
-        </p:txBody>
-      </p:sp>
-      <p:sp>
-        <p:nvSpPr>
-          <p:cNvPr id="7" name="Rounded Rectangle 6"/>
+              <a:t>Primo分析サービス LP立ち上げ　ご依頼内容</a:t>
+            </a:r>
+          </a:p>
+        </p:txBody>
+      </p:sp>
+      <p:sp>
+        <p:nvSpPr>
+          <p:cNvPr id="5" name="Rounded Rectangle 4"/>
           <p:cNvSpPr/>
           <p:nvPr/>
         </p:nvSpPr>
         <p:spPr>
           <a:xfrm>
-            <a:off x="548640" y="1783080"/>
-            <a:ext cx="5303520" cy="1051560"/>
+            <a:off x="548640" y="868680"/>
+            <a:ext cx="11064240" cy="384048"/>
           </a:xfrm>
           <a:prstGeom prst="roundRect">
             <a:avLst/>
           </a:prstGeom>
           <a:solidFill>
-            <a:srgbClr val="F4F7FA"/>
+            <a:srgbClr val="FFF8F0"/>
           </a:solidFill>
-          <a:ln w="9525">
+          <a:ln w="12700">
             <a:solidFill>
-              <a:srgbClr val="DDE3EA"/>
+              <a:srgbClr val="E86C00"/>
             </a:solidFill>
           </a:ln>
         </p:spPr>
@@ -3326,23 +3256,95 @@
       </p:sp>
       <p:sp>
         <p:nvSpPr>
-          <p:cNvPr id="8" name="Oval 7"/>
+          <p:cNvPr id="6" name="TextBox 5"/>
+          <p:cNvSpPr txBox="1"/>
+          <p:nvPr/>
+        </p:nvSpPr>
+        <p:spPr>
+          <a:xfrm>
+            <a:off x="731520" y="914400"/>
+            <a:ext cx="10698480" cy="320040"/>
+          </a:xfrm>
+          <a:prstGeom prst="rect">
+            <a:avLst/>
+          </a:prstGeom>
+          <a:noFill/>
+        </p:spPr>
+        <p:txBody>
+          <a:bodyPr wrap="none">
+            <a:spAutoFit/>
+          </a:bodyPr>
+          <a:lstStyle/>
+          <a:p>
+            <a:pPr>
+              <a:defRPr sz="1300" b="1">
+                <a:solidFill>
+                  <a:srgbClr val="E86C00"/>
+                </a:solidFill>
+              </a:defRPr>
+            </a:pPr>
+            <a:r>
+              <a:t>依頼元：フライト（Flight）　→　ご依頼先：牛尾様</a:t>
+            </a:r>
+          </a:p>
+        </p:txBody>
+      </p:sp>
+      <p:sp>
+        <p:nvSpPr>
+          <p:cNvPr id="7" name="TextBox 6"/>
+          <p:cNvSpPr txBox="1"/>
+          <p:nvPr/>
+        </p:nvSpPr>
+        <p:spPr>
+          <a:xfrm>
+            <a:off x="548640" y="1417320"/>
+            <a:ext cx="5303520" cy="320040"/>
+          </a:xfrm>
+          <a:prstGeom prst="rect">
+            <a:avLst/>
+          </a:prstGeom>
+          <a:noFill/>
+        </p:spPr>
+        <p:txBody>
+          <a:bodyPr wrap="none">
+            <a:spAutoFit/>
+          </a:bodyPr>
+          <a:lstStyle/>
+          <a:p>
+            <a:pPr>
+              <a:defRPr sz="1500" b="1">
+                <a:solidFill>
+                  <a:srgbClr val="1A3A5C"/>
+                </a:solidFill>
+              </a:defRPr>
+            </a:pPr>
+            <a:r>
+              <a:t>スケジュール・工程</a:t>
+            </a:r>
+          </a:p>
+        </p:txBody>
+      </p:sp>
+      <p:sp>
+        <p:nvSpPr>
+          <p:cNvPr id="8" name="Rounded Rectangle 7"/>
           <p:cNvSpPr/>
           <p:nvPr/>
         </p:nvSpPr>
         <p:spPr>
           <a:xfrm>
-            <a:off x="685800" y="1920240"/>
-            <a:ext cx="411480" cy="411480"/>
-          </a:xfrm>
-          <a:prstGeom prst="ellipse">
+            <a:off x="548640" y="1828800"/>
+            <a:ext cx="5303520" cy="1051560"/>
+          </a:xfrm>
+          <a:prstGeom prst="roundRect">
             <a:avLst/>
           </a:prstGeom>
           <a:solidFill>
-            <a:srgbClr val="2E86AB"/>
+            <a:srgbClr val="F4F7FA"/>
           </a:solidFill>
-          <a:ln>
-            <a:noFill/>
+          <a:ln w="9525">
+            <a:solidFill>
+              <a:srgbClr val="DDE3EA"/>
+            </a:solidFill>
           </a:ln>
         </p:spPr>
         <p:style>
@@ -3363,90 +3365,29 @@
           <a:bodyPr rtlCol="0" anchor="ctr"/>
           <a:lstStyle/>
           <a:p>
-            <a:pPr algn="ctr">
-              <a:defRPr sz="1400" b="1">
-                <a:solidFill>
-                  <a:srgbClr val="FFFFFF"/>
-                </a:solidFill>
-              </a:defRPr>
-            </a:pPr>
-            <a:r>
-              <a:t>①</a:t>
-            </a:r>
-          </a:p>
-        </p:txBody>
-      </p:sp>
-      <p:sp>
-        <p:nvSpPr>
-          <p:cNvPr id="9" name="TextBox 8"/>
-          <p:cNvSpPr txBox="1"/>
-          <p:nvPr/>
-        </p:nvSpPr>
-        <p:spPr>
-          <a:xfrm>
-            <a:off x="1234440" y="1892808"/>
-            <a:ext cx="4480560" cy="868680"/>
-          </a:xfrm>
-          <a:prstGeom prst="rect">
-            <a:avLst/>
-          </a:prstGeom>
-          <a:noFill/>
-        </p:spPr>
-        <p:txBody>
-          <a:bodyPr wrap="square">
-            <a:spAutoFit/>
-          </a:bodyPr>
-          <a:lstStyle/>
-          <a:p>
-            <a:pPr>
-              <a:defRPr sz="1200" b="1">
-                <a:solidFill>
-                  <a:srgbClr val="1A3A5C"/>
-                </a:solidFill>
-              </a:defRPr>
-            </a:pPr>
-            <a:r>
-              <a:t>〜7/15　デザインコンテンツの作成</a:t>
-            </a:r>
-          </a:p>
-          <a:p>
-            <a:pPr>
-              <a:spcBef>
-                <a:spcPts val="400"/>
-              </a:spcBef>
-              <a:defRPr sz="1000">
-                <a:solidFill>
-                  <a:srgbClr val="999999"/>
-                </a:solidFill>
-              </a:defRPr>
-            </a:pPr>
-            <a:r>
-              <a:t>担当：BI会社</a:t>
-            </a:r>
-          </a:p>
-        </p:txBody>
-      </p:sp>
-      <p:sp>
-        <p:nvSpPr>
-          <p:cNvPr id="10" name="Rounded Rectangle 9"/>
+            <a:pPr algn="ctr"/>
+          </a:p>
+        </p:txBody>
+      </p:sp>
+      <p:sp>
+        <p:nvSpPr>
+          <p:cNvPr id="9" name="Oval 8"/>
           <p:cNvSpPr/>
           <p:nvPr/>
         </p:nvSpPr>
         <p:spPr>
           <a:xfrm>
-            <a:off x="548640" y="3017520"/>
-            <a:ext cx="5303520" cy="1051560"/>
-          </a:xfrm>
-          <a:prstGeom prst="roundRect">
+            <a:off x="685800" y="1965960"/>
+            <a:ext cx="411480" cy="411480"/>
+          </a:xfrm>
+          <a:prstGeom prst="ellipse">
             <a:avLst/>
           </a:prstGeom>
           <a:solidFill>
-            <a:srgbClr val="F4F7FA"/>
+            <a:srgbClr val="1A3A5C"/>
           </a:solidFill>
-          <a:ln w="9525">
-            <a:solidFill>
-              <a:srgbClr val="DDE3EA"/>
-            </a:solidFill>
+          <a:ln>
+            <a:noFill/>
           </a:ln>
         </p:spPr>
         <p:style>
@@ -3467,29 +3408,90 @@
           <a:bodyPr rtlCol="0" anchor="ctr"/>
           <a:lstStyle/>
           <a:p>
-            <a:pPr algn="ctr"/>
-          </a:p>
-        </p:txBody>
-      </p:sp>
-      <p:sp>
-        <p:nvSpPr>
-          <p:cNvPr id="11" name="Oval 10"/>
+            <a:pPr algn="ctr">
+              <a:defRPr sz="1400" b="1">
+                <a:solidFill>
+                  <a:srgbClr val="FFFFFF"/>
+                </a:solidFill>
+              </a:defRPr>
+            </a:pPr>
+            <a:r>
+              <a:t>①</a:t>
+            </a:r>
+          </a:p>
+        </p:txBody>
+      </p:sp>
+      <p:sp>
+        <p:nvSpPr>
+          <p:cNvPr id="10" name="TextBox 9"/>
+          <p:cNvSpPr txBox="1"/>
+          <p:nvPr/>
+        </p:nvSpPr>
+        <p:spPr>
+          <a:xfrm>
+            <a:off x="1234440" y="1920240"/>
+            <a:ext cx="4480560" cy="914400"/>
+          </a:xfrm>
+          <a:prstGeom prst="rect">
+            <a:avLst/>
+          </a:prstGeom>
+          <a:noFill/>
+        </p:spPr>
+        <p:txBody>
+          <a:bodyPr wrap="square">
+            <a:spAutoFit/>
+          </a:bodyPr>
+          <a:lstStyle/>
+          <a:p>
+            <a:pPr>
+              <a:defRPr sz="1150" b="1">
+                <a:solidFill>
+                  <a:srgbClr val="1A3A5C"/>
+                </a:solidFill>
+              </a:defRPr>
+            </a:pPr>
+            <a:r>
+              <a:t>〜7/15　デザインコンテンツの作成</a:t>
+            </a:r>
+          </a:p>
+          <a:p>
+            <a:pPr>
+              <a:spcBef>
+                <a:spcPts val="300"/>
+              </a:spcBef>
+              <a:defRPr sz="1000" b="0">
+                <a:solidFill>
+                  <a:srgbClr val="999999"/>
+                </a:solidFill>
+              </a:defRPr>
+            </a:pPr>
+            <a:r>
+              <a:t>担当：BI会社</a:t>
+            </a:r>
+          </a:p>
+        </p:txBody>
+      </p:sp>
+      <p:sp>
+        <p:nvSpPr>
+          <p:cNvPr id="11" name="Rounded Rectangle 10"/>
           <p:cNvSpPr/>
           <p:nvPr/>
         </p:nvSpPr>
         <p:spPr>
           <a:xfrm>
-            <a:off x="685800" y="3154680"/>
-            <a:ext cx="411480" cy="411480"/>
-          </a:xfrm>
-          <a:prstGeom prst="ellipse">
+            <a:off x="548640" y="3063240"/>
+            <a:ext cx="5303520" cy="1051560"/>
+          </a:xfrm>
+          <a:prstGeom prst="roundRect">
             <a:avLst/>
           </a:prstGeom>
           <a:solidFill>
-            <a:srgbClr val="1A3A5C"/>
+            <a:srgbClr val="FFF8F0"/>
           </a:solidFill>
-          <a:ln>
-            <a:noFill/>
+          <a:ln w="15240">
+            <a:solidFill>
+              <a:srgbClr val="E86C00"/>
+            </a:solidFill>
           </a:ln>
         </p:spPr>
         <p:style>
@@ -3510,90 +3512,29 @@
           <a:bodyPr rtlCol="0" anchor="ctr"/>
           <a:lstStyle/>
           <a:p>
-            <a:pPr algn="ctr">
-              <a:defRPr sz="1400" b="1">
-                <a:solidFill>
-                  <a:srgbClr val="FFFFFF"/>
-                </a:solidFill>
-              </a:defRPr>
-            </a:pPr>
-            <a:r>
-              <a:t>②</a:t>
-            </a:r>
-          </a:p>
-        </p:txBody>
-      </p:sp>
-      <p:sp>
-        <p:nvSpPr>
-          <p:cNvPr id="12" name="TextBox 11"/>
-          <p:cNvSpPr txBox="1"/>
-          <p:nvPr/>
-        </p:nvSpPr>
-        <p:spPr>
-          <a:xfrm>
-            <a:off x="1234440" y="3127248"/>
-            <a:ext cx="4480560" cy="868680"/>
-          </a:xfrm>
-          <a:prstGeom prst="rect">
-            <a:avLst/>
-          </a:prstGeom>
-          <a:noFill/>
-        </p:spPr>
-        <p:txBody>
-          <a:bodyPr wrap="square">
-            <a:spAutoFit/>
-          </a:bodyPr>
-          <a:lstStyle/>
-          <a:p>
-            <a:pPr>
-              <a:defRPr sz="1200" b="1">
-                <a:solidFill>
-                  <a:srgbClr val="1A3A5C"/>
-                </a:solidFill>
-              </a:defRPr>
-            </a:pPr>
-            <a:r>
-              <a:t>7/17〜31頃　デザインコンテンツへのFB</a:t>
-            </a:r>
-          </a:p>
-          <a:p>
-            <a:pPr>
-              <a:spcBef>
-                <a:spcPts val="400"/>
-              </a:spcBef>
-              <a:defRPr sz="1000">
-                <a:solidFill>
-                  <a:srgbClr val="999999"/>
-                </a:solidFill>
-              </a:defRPr>
-            </a:pPr>
-            <a:r>
-              <a:t>担当：フライト</a:t>
-            </a:r>
-          </a:p>
-        </p:txBody>
-      </p:sp>
-      <p:sp>
-        <p:nvSpPr>
-          <p:cNvPr id="13" name="Rounded Rectangle 12"/>
+            <a:pPr algn="ctr"/>
+          </a:p>
+        </p:txBody>
+      </p:sp>
+      <p:sp>
+        <p:nvSpPr>
+          <p:cNvPr id="12" name="Oval 11"/>
           <p:cNvSpPr/>
           <p:nvPr/>
         </p:nvSpPr>
         <p:spPr>
           <a:xfrm>
-            <a:off x="548640" y="4251960"/>
-            <a:ext cx="5303520" cy="1051560"/>
-          </a:xfrm>
-          <a:prstGeom prst="roundRect">
+            <a:off x="685800" y="3200400"/>
+            <a:ext cx="411480" cy="411480"/>
+          </a:xfrm>
+          <a:prstGeom prst="ellipse">
             <a:avLst/>
           </a:prstGeom>
           <a:solidFill>
-            <a:srgbClr val="F4F7FA"/>
+            <a:srgbClr val="E86C00"/>
           </a:solidFill>
-          <a:ln w="9525">
-            <a:solidFill>
-              <a:srgbClr val="DDE3EA"/>
-            </a:solidFill>
+          <a:ln>
+            <a:noFill/>
           </a:ln>
         </p:spPr>
         <p:style>
@@ -3614,29 +3555,90 @@
           <a:bodyPr rtlCol="0" anchor="ctr"/>
           <a:lstStyle/>
           <a:p>
-            <a:pPr algn="ctr"/>
-          </a:p>
-        </p:txBody>
-      </p:sp>
-      <p:sp>
-        <p:nvSpPr>
-          <p:cNvPr id="14" name="Oval 13"/>
+            <a:pPr algn="ctr">
+              <a:defRPr sz="1400" b="1">
+                <a:solidFill>
+                  <a:srgbClr val="FFFFFF"/>
+                </a:solidFill>
+              </a:defRPr>
+            </a:pPr>
+            <a:r>
+              <a:t>②</a:t>
+            </a:r>
+          </a:p>
+        </p:txBody>
+      </p:sp>
+      <p:sp>
+        <p:nvSpPr>
+          <p:cNvPr id="13" name="TextBox 12"/>
+          <p:cNvSpPr txBox="1"/>
+          <p:nvPr/>
+        </p:nvSpPr>
+        <p:spPr>
+          <a:xfrm>
+            <a:off x="1234440" y="3154680"/>
+            <a:ext cx="4480560" cy="914400"/>
+          </a:xfrm>
+          <a:prstGeom prst="rect">
+            <a:avLst/>
+          </a:prstGeom>
+          <a:noFill/>
+        </p:spPr>
+        <p:txBody>
+          <a:bodyPr wrap="square">
+            <a:spAutoFit/>
+          </a:bodyPr>
+          <a:lstStyle/>
+          <a:p>
+            <a:pPr>
+              <a:defRPr sz="1150" b="1">
+                <a:solidFill>
+                  <a:srgbClr val="1A3A5C"/>
+                </a:solidFill>
+              </a:defRPr>
+            </a:pPr>
+            <a:r>
+              <a:t>7/17〜31頃　デザインコンテンツへのFB</a:t>
+            </a:r>
+          </a:p>
+          <a:p>
+            <a:pPr>
+              <a:spcBef>
+                <a:spcPts val="300"/>
+              </a:spcBef>
+              <a:defRPr sz="1000" b="1">
+                <a:solidFill>
+                  <a:srgbClr val="E86C00"/>
+                </a:solidFill>
+              </a:defRPr>
+            </a:pPr>
+            <a:r>
+              <a:t>担当：牛尾様（フライトよりご依頼）</a:t>
+            </a:r>
+          </a:p>
+        </p:txBody>
+      </p:sp>
+      <p:sp>
+        <p:nvSpPr>
+          <p:cNvPr id="14" name="Rounded Rectangle 13"/>
           <p:cNvSpPr/>
           <p:nvPr/>
         </p:nvSpPr>
         <p:spPr>
           <a:xfrm>
-            <a:off x="685800" y="4389120"/>
-            <a:ext cx="411480" cy="411480"/>
-          </a:xfrm>
-          <a:prstGeom prst="ellipse">
+            <a:off x="548640" y="4297680"/>
+            <a:ext cx="5303520" cy="1051560"/>
+          </a:xfrm>
+          <a:prstGeom prst="roundRect">
             <a:avLst/>
           </a:prstGeom>
           <a:solidFill>
-            <a:srgbClr val="1A3A5C"/>
+            <a:srgbClr val="FFF8F0"/>
           </a:solidFill>
-          <a:ln>
-            <a:noFill/>
+          <a:ln w="15240">
+            <a:solidFill>
+              <a:srgbClr val="E86C00"/>
+            </a:solidFill>
           </a:ln>
         </p:spPr>
         <p:style>
@@ -3657,164 +3659,29 @@
           <a:bodyPr rtlCol="0" anchor="ctr"/>
           <a:lstStyle/>
           <a:p>
-            <a:pPr algn="ctr">
-              <a:defRPr sz="1400" b="1">
-                <a:solidFill>
-                  <a:srgbClr val="FFFFFF"/>
-                </a:solidFill>
-              </a:defRPr>
-            </a:pPr>
-            <a:r>
-              <a:t>③</a:t>
-            </a:r>
-          </a:p>
-        </p:txBody>
-      </p:sp>
-      <p:sp>
-        <p:nvSpPr>
-          <p:cNvPr id="15" name="TextBox 14"/>
-          <p:cNvSpPr txBox="1"/>
-          <p:nvPr/>
-        </p:nvSpPr>
-        <p:spPr>
-          <a:xfrm>
-            <a:off x="1234440" y="4361688"/>
-            <a:ext cx="4480560" cy="868680"/>
-          </a:xfrm>
-          <a:prstGeom prst="rect">
-            <a:avLst/>
-          </a:prstGeom>
-          <a:noFill/>
-        </p:spPr>
-        <p:txBody>
-          <a:bodyPr wrap="square">
-            <a:spAutoFit/>
-          </a:bodyPr>
-          <a:lstStyle/>
-          <a:p>
-            <a:pPr>
-              <a:defRPr sz="1200" b="1">
-                <a:solidFill>
-                  <a:srgbClr val="1A3A5C"/>
-                </a:solidFill>
-              </a:defRPr>
-            </a:pPr>
-            <a:r>
-              <a:t>8/1〜21頃　デザインコーディング</a:t>
-            </a:r>
-            <a:br/>
-            <a:r>
-              <a:t>セールスサイトへの組み込み</a:t>
-            </a:r>
-          </a:p>
-          <a:p>
-            <a:pPr>
-              <a:spcBef>
-                <a:spcPts val="400"/>
-              </a:spcBef>
-              <a:defRPr sz="1000">
-                <a:solidFill>
-                  <a:srgbClr val="999999"/>
-                </a:solidFill>
-              </a:defRPr>
-            </a:pPr>
-            <a:r>
-              <a:t>担当：フライト担当</a:t>
-            </a:r>
-          </a:p>
-        </p:txBody>
-      </p:sp>
-      <p:sp>
-        <p:nvSpPr>
-          <p:cNvPr id="16" name="TextBox 15"/>
-          <p:cNvSpPr txBox="1"/>
-          <p:nvPr/>
-        </p:nvSpPr>
-        <p:spPr>
-          <a:xfrm>
-            <a:off x="548640" y="5486400"/>
-            <a:ext cx="5303520" cy="320040"/>
-          </a:xfrm>
-          <a:prstGeom prst="rect">
-            <a:avLst/>
-          </a:prstGeom>
-          <a:noFill/>
-        </p:spPr>
-        <p:txBody>
-          <a:bodyPr wrap="none">
-            <a:spAutoFit/>
-          </a:bodyPr>
-          <a:lstStyle/>
-          <a:p>
-            <a:pPr>
-              <a:defRPr sz="900" i="1">
-                <a:solidFill>
-                  <a:srgbClr val="999999"/>
-                </a:solidFill>
-              </a:defRPr>
-            </a:pPr>
-            <a:r>
-              <a:t>※ スケジュールは若干の調整可能</a:t>
-            </a:r>
-          </a:p>
-        </p:txBody>
-      </p:sp>
-      <p:sp>
-        <p:nvSpPr>
-          <p:cNvPr id="17" name="TextBox 16"/>
-          <p:cNvSpPr txBox="1"/>
-          <p:nvPr/>
-        </p:nvSpPr>
-        <p:spPr>
-          <a:xfrm>
-            <a:off x="6217920" y="1371600"/>
-            <a:ext cx="5394960" cy="320040"/>
-          </a:xfrm>
-          <a:prstGeom prst="rect">
-            <a:avLst/>
-          </a:prstGeom>
-          <a:noFill/>
-        </p:spPr>
-        <p:txBody>
-          <a:bodyPr wrap="none">
-            <a:spAutoFit/>
-          </a:bodyPr>
-          <a:lstStyle/>
-          <a:p>
-            <a:pPr>
-              <a:defRPr sz="1600" b="1">
-                <a:solidFill>
-                  <a:srgbClr val="1A3A5C"/>
-                </a:solidFill>
-              </a:defRPr>
-            </a:pPr>
-            <a:r>
-              <a:t>役割と責任範囲（フライト側）</a:t>
-            </a:r>
-          </a:p>
-        </p:txBody>
-      </p:sp>
-      <p:sp>
-        <p:nvSpPr>
-          <p:cNvPr id="18" name="Rounded Rectangle 17"/>
+            <a:pPr algn="ctr"/>
+          </a:p>
+        </p:txBody>
+      </p:sp>
+      <p:sp>
+        <p:nvSpPr>
+          <p:cNvPr id="15" name="Oval 14"/>
           <p:cNvSpPr/>
           <p:nvPr/>
         </p:nvSpPr>
         <p:spPr>
           <a:xfrm>
-            <a:off x="6217920" y="1783080"/>
-            <a:ext cx="5394960" cy="1874519"/>
-          </a:xfrm>
-          <a:prstGeom prst="roundRect">
+            <a:off x="685800" y="4434840"/>
+            <a:ext cx="411480" cy="411480"/>
+          </a:xfrm>
+          <a:prstGeom prst="ellipse">
             <a:avLst/>
           </a:prstGeom>
           <a:solidFill>
-            <a:srgbClr val="F4F7FA"/>
+            <a:srgbClr val="E86C00"/>
           </a:solidFill>
-          <a:ln w="9525">
-            <a:solidFill>
-              <a:srgbClr val="DDE3EA"/>
-            </a:solidFill>
+          <a:ln>
+            <a:noFill/>
           </a:ln>
         </p:spPr>
         <p:style>
@@ -3835,26 +3702,124 @@
           <a:bodyPr rtlCol="0" anchor="ctr"/>
           <a:lstStyle/>
           <a:p>
-            <a:pPr algn="ctr"/>
-          </a:p>
-        </p:txBody>
-      </p:sp>
-      <p:sp>
-        <p:nvSpPr>
-          <p:cNvPr id="19" name="Rectangle 18"/>
+            <a:pPr algn="ctr">
+              <a:defRPr sz="1400" b="1">
+                <a:solidFill>
+                  <a:srgbClr val="FFFFFF"/>
+                </a:solidFill>
+              </a:defRPr>
+            </a:pPr>
+            <a:r>
+              <a:t>③</a:t>
+            </a:r>
+          </a:p>
+        </p:txBody>
+      </p:sp>
+      <p:sp>
+        <p:nvSpPr>
+          <p:cNvPr id="16" name="TextBox 15"/>
+          <p:cNvSpPr txBox="1"/>
+          <p:nvPr/>
+        </p:nvSpPr>
+        <p:spPr>
+          <a:xfrm>
+            <a:off x="1234440" y="4389120"/>
+            <a:ext cx="4480560" cy="914400"/>
+          </a:xfrm>
+          <a:prstGeom prst="rect">
+            <a:avLst/>
+          </a:prstGeom>
+          <a:noFill/>
+        </p:spPr>
+        <p:txBody>
+          <a:bodyPr wrap="square">
+            <a:spAutoFit/>
+          </a:bodyPr>
+          <a:lstStyle/>
+          <a:p>
+            <a:pPr>
+              <a:defRPr sz="1150" b="1">
+                <a:solidFill>
+                  <a:srgbClr val="1A3A5C"/>
+                </a:solidFill>
+              </a:defRPr>
+            </a:pPr>
+            <a:r>
+              <a:t>8/1〜21頃　デザインコーディング</a:t>
+            </a:r>
+            <a:br/>
+            <a:r>
+              <a:t>セールスサイトへの組み込み</a:t>
+            </a:r>
+          </a:p>
+          <a:p>
+            <a:pPr>
+              <a:spcBef>
+                <a:spcPts val="300"/>
+              </a:spcBef>
+              <a:defRPr sz="1000" b="1">
+                <a:solidFill>
+                  <a:srgbClr val="E86C00"/>
+                </a:solidFill>
+              </a:defRPr>
+            </a:pPr>
+            <a:r>
+              <a:t>担当：牛尾様（フライトよりご依頼）</a:t>
+            </a:r>
+          </a:p>
+        </p:txBody>
+      </p:sp>
+      <p:sp>
+        <p:nvSpPr>
+          <p:cNvPr id="17" name="TextBox 16"/>
+          <p:cNvSpPr txBox="1"/>
+          <p:nvPr/>
+        </p:nvSpPr>
+        <p:spPr>
+          <a:xfrm>
+            <a:off x="548640" y="5532120"/>
+            <a:ext cx="5303520" cy="320040"/>
+          </a:xfrm>
+          <a:prstGeom prst="rect">
+            <a:avLst/>
+          </a:prstGeom>
+          <a:noFill/>
+        </p:spPr>
+        <p:txBody>
+          <a:bodyPr wrap="none">
+            <a:spAutoFit/>
+          </a:bodyPr>
+          <a:lstStyle/>
+          <a:p>
+            <a:pPr>
+              <a:defRPr sz="900" i="1">
+                <a:solidFill>
+                  <a:srgbClr val="999999"/>
+                </a:solidFill>
+              </a:defRPr>
+            </a:pPr>
+            <a:r>
+              <a:t>※ スケジュールは若干の調整可能</a:t>
+            </a:r>
+          </a:p>
+        </p:txBody>
+      </p:sp>
+      <p:sp>
+        <p:nvSpPr>
+          <p:cNvPr id="18" name="Rectangle 17"/>
           <p:cNvSpPr/>
           <p:nvPr/>
         </p:nvSpPr>
         <p:spPr>
           <a:xfrm>
-            <a:off x="6217920" y="1783080"/>
-            <a:ext cx="5394960" cy="384048"/>
+            <a:off x="5989320" y="1417320"/>
+            <a:ext cx="18288" cy="4434840"/>
           </a:xfrm>
           <a:prstGeom prst="rect">
             <a:avLst/>
           </a:prstGeom>
           <a:solidFill>
-            <a:srgbClr val="1A3A5C"/>
+            <a:srgbClr val="DDE3EA"/>
           </a:solidFill>
           <a:ln>
             <a:noFill/>
@@ -3884,14 +3849,14 @@
       </p:sp>
       <p:sp>
         <p:nvSpPr>
-          <p:cNvPr id="20" name="TextBox 19"/>
+          <p:cNvPr id="19" name="TextBox 18"/>
           <p:cNvSpPr txBox="1"/>
           <p:nvPr/>
         </p:nvSpPr>
         <p:spPr>
           <a:xfrm>
-            <a:off x="6400800" y="1828800"/>
-            <a:ext cx="5120640" cy="320040"/>
+            <a:off x="6217920" y="1417320"/>
+            <a:ext cx="5394960" cy="320040"/>
           </a:xfrm>
           <a:prstGeom prst="rect">
             <a:avLst/>
@@ -3905,133 +3870,38 @@
           <a:lstStyle/>
           <a:p>
             <a:pPr>
-              <a:defRPr sz="1200" b="1">
+              <a:defRPr sz="1500" b="1">
                 <a:solidFill>
-                  <a:srgbClr val="FFFFFF"/>
+                  <a:srgbClr val="1A3A5C"/>
                 </a:solidFill>
               </a:defRPr>
             </a:pPr>
             <a:r>
-              <a:t>②  FBフェーズ（アドバイザー）</a:t>
-            </a:r>
-          </a:p>
-        </p:txBody>
-      </p:sp>
-      <p:sp>
-        <p:nvSpPr>
-          <p:cNvPr id="21" name="TextBox 20"/>
-          <p:cNvSpPr txBox="1"/>
-          <p:nvPr/>
-        </p:nvSpPr>
-        <p:spPr>
-          <a:xfrm>
-            <a:off x="6446520" y="2240280"/>
-            <a:ext cx="5029200" cy="1325880"/>
-          </a:xfrm>
-          <a:prstGeom prst="rect">
-            <a:avLst/>
-          </a:prstGeom>
-          <a:noFill/>
-        </p:spPr>
-        <p:txBody>
-          <a:bodyPr wrap="square">
-            <a:spAutoFit/>
-          </a:bodyPr>
-          <a:lstStyle/>
-          <a:p>
-            <a:pPr>
-              <a:defRPr sz="1000" b="1">
-                <a:solidFill>
-                  <a:srgbClr val="2E86AB"/>
-                </a:solidFill>
-              </a:defRPr>
-            </a:pPr>
-            <a:r>
-              <a:t>担当：フライト</a:t>
-            </a:r>
-          </a:p>
-          <a:p>
-            <a:pPr>
-              <a:spcBef>
-                <a:spcPts val="300"/>
-              </a:spcBef>
-              <a:defRPr sz="1000">
-                <a:solidFill>
-                  <a:srgbClr val="555555"/>
-                </a:solidFill>
-              </a:defRPr>
-            </a:pPr>
-            <a:r>
-              <a:t>・BI会社が共有するデザインコンテンツへのFB</a:t>
-            </a:r>
-          </a:p>
-          <a:p>
-            <a:pPr>
-              <a:spcBef>
-                <a:spcPts val="300"/>
-              </a:spcBef>
-              <a:defRPr sz="1000">
-                <a:solidFill>
-                  <a:srgbClr val="555555"/>
-                </a:solidFill>
-              </a:defRPr>
-            </a:pPr>
-            <a:r>
-              <a:t>・LPの情報設計・セールスサイトとの導線を中心に助言</a:t>
-            </a:r>
-          </a:p>
-          <a:p>
-            <a:pPr>
-              <a:spcBef>
-                <a:spcPts val="300"/>
-              </a:spcBef>
-              <a:defRPr sz="1000">
-                <a:solidFill>
-                  <a:srgbClr val="555555"/>
-                </a:solidFill>
-              </a:defRPr>
-            </a:pPr>
-            <a:r>
-              <a:t>・現行セールスサイトの設計を踏まえた指摘</a:t>
-            </a:r>
-          </a:p>
-          <a:p>
-            <a:pPr>
-              <a:spcBef>
-                <a:spcPts val="600"/>
-              </a:spcBef>
-              <a:defRPr sz="900" i="1">
-                <a:solidFill>
-                  <a:srgbClr val="999999"/>
-                </a:solidFill>
-              </a:defRPr>
-            </a:pPr>
-            <a:r>
-              <a:t>→ BI会社とのやり取りは発生しない想定</a:t>
-            </a:r>
-          </a:p>
-        </p:txBody>
-      </p:sp>
-      <p:sp>
-        <p:nvSpPr>
-          <p:cNvPr id="22" name="Rounded Rectangle 21"/>
+              <a:t>牛尾様へのご依頼と責任範囲</a:t>
+            </a:r>
+          </a:p>
+        </p:txBody>
+      </p:sp>
+      <p:sp>
+        <p:nvSpPr>
+          <p:cNvPr id="20" name="Rounded Rectangle 19"/>
           <p:cNvSpPr/>
           <p:nvPr/>
         </p:nvSpPr>
         <p:spPr>
           <a:xfrm>
-            <a:off x="6217920" y="3840480"/>
-            <a:ext cx="5394960" cy="1874519"/>
+            <a:off x="6217920" y="1828800"/>
+            <a:ext cx="5394960" cy="1965960"/>
           </a:xfrm>
           <a:prstGeom prst="roundRect">
             <a:avLst/>
           </a:prstGeom>
           <a:solidFill>
-            <a:srgbClr val="F4F7FA"/>
+            <a:srgbClr val="FFF8F0"/>
           </a:solidFill>
-          <a:ln w="9525">
+          <a:ln w="12700">
             <a:solidFill>
-              <a:srgbClr val="DDE3EA"/>
+              <a:srgbClr val="E86C00"/>
             </a:solidFill>
           </a:ln>
         </p:spPr>
@@ -4059,20 +3929,20 @@
       </p:sp>
       <p:sp>
         <p:nvSpPr>
-          <p:cNvPr id="23" name="Rectangle 22"/>
+          <p:cNvPr id="21" name="Rectangle 20"/>
           <p:cNvSpPr/>
           <p:nvPr/>
         </p:nvSpPr>
         <p:spPr>
           <a:xfrm>
-            <a:off x="6217920" y="3840480"/>
-            <a:ext cx="5394960" cy="384048"/>
+            <a:off x="6217920" y="1828800"/>
+            <a:ext cx="5394960" cy="411480"/>
           </a:xfrm>
           <a:prstGeom prst="rect">
             <a:avLst/>
           </a:prstGeom>
           <a:solidFill>
-            <a:srgbClr val="1A3A5C"/>
+            <a:srgbClr val="E86C00"/>
           </a:solidFill>
           <a:ln>
             <a:noFill/>
@@ -4102,14 +3972,14 @@
       </p:sp>
       <p:sp>
         <p:nvSpPr>
-          <p:cNvPr id="24" name="TextBox 23"/>
+          <p:cNvPr id="22" name="TextBox 21"/>
           <p:cNvSpPr txBox="1"/>
           <p:nvPr/>
         </p:nvSpPr>
         <p:spPr>
           <a:xfrm>
-            <a:off x="6400800" y="3886200"/>
-            <a:ext cx="5120640" cy="320040"/>
+            <a:off x="6400800" y="1883664"/>
+            <a:ext cx="5120640" cy="347472"/>
           </a:xfrm>
           <a:prstGeom prst="rect">
             <a:avLst/>
@@ -4123,28 +3993,28 @@
           <a:lstStyle/>
           <a:p>
             <a:pPr>
-              <a:defRPr sz="1200" b="1">
+              <a:defRPr sz="1150" b="1">
                 <a:solidFill>
                   <a:srgbClr val="FFFFFF"/>
                 </a:solidFill>
               </a:defRPr>
             </a:pPr>
             <a:r>
-              <a:t>③  コーディング・組み込み</a:t>
-            </a:r>
-          </a:p>
-        </p:txBody>
-      </p:sp>
-      <p:sp>
-        <p:nvSpPr>
-          <p:cNvPr id="25" name="TextBox 24"/>
+              <a:t>②  FBフェーズ（アドバイザーとしてのご助言）</a:t>
+            </a:r>
+          </a:p>
+        </p:txBody>
+      </p:sp>
+      <p:sp>
+        <p:nvSpPr>
+          <p:cNvPr id="23" name="TextBox 22"/>
           <p:cNvSpPr txBox="1"/>
           <p:nvPr/>
         </p:nvSpPr>
         <p:spPr>
           <a:xfrm>
-            <a:off x="6446520" y="4297680"/>
-            <a:ext cx="5029200" cy="1325880"/>
+            <a:off x="6446520" y="2304288"/>
+            <a:ext cx="5029200" cy="1417320"/>
           </a:xfrm>
           <a:prstGeom prst="rect">
             <a:avLst/>
@@ -4158,20 +4028,20 @@
           <a:lstStyle/>
           <a:p>
             <a:pPr>
-              <a:defRPr sz="1000" b="1">
+              <a:defRPr sz="1000">
                 <a:solidFill>
-                  <a:srgbClr val="2E86AB"/>
+                  <a:srgbClr val="555555"/>
                 </a:solidFill>
               </a:defRPr>
             </a:pPr>
             <a:r>
-              <a:t>担当：フライト担当</a:t>
+              <a:t>・BI会社が共有するデザインコンテンツへのFB</a:t>
             </a:r>
           </a:p>
           <a:p>
             <a:pPr>
               <a:spcBef>
-                <a:spcPts val="300"/>
+                <a:spcPts val="200"/>
               </a:spcBef>
               <a:defRPr sz="1000">
                 <a:solidFill>
@@ -4180,13 +4050,13 @@
               </a:defRPr>
             </a:pPr>
             <a:r>
-              <a:t>・②でFIXしたデザインのコーディング</a:t>
+              <a:t>・LPの情報設計・セールスサイトとの導線など</a:t>
             </a:r>
           </a:p>
           <a:p>
             <a:pPr>
               <a:spcBef>
-                <a:spcPts val="300"/>
+                <a:spcPts val="200"/>
               </a:spcBef>
               <a:defRPr sz="1000">
                 <a:solidFill>
@@ -4195,13 +4065,28 @@
               </a:defRPr>
             </a:pPr>
             <a:r>
-              <a:t>・セールスサイトへの組み込み</a:t>
+              <a:t>・セールスサイト全体を見たうえでのアドバイスも歓迎</a:t>
             </a:r>
           </a:p>
           <a:p>
             <a:pPr>
               <a:spcBef>
                 <a:spcPts val="600"/>
+              </a:spcBef>
+              <a:defRPr sz="950" b="1">
+                <a:solidFill>
+                  <a:srgbClr val="1A3A5C"/>
+                </a:solidFill>
+              </a:defRPr>
+            </a:pPr>
+            <a:r>
+              <a:t>▶ アドバイザーとしての助言をお願いするもの</a:t>
+            </a:r>
+          </a:p>
+          <a:p>
+            <a:pPr>
+              <a:spcBef>
+                <a:spcPts val="400"/>
               </a:spcBef>
               <a:defRPr sz="900" i="1">
                 <a:solidFill>
@@ -4210,30 +4095,32 @@
               </a:defRPr>
             </a:pPr>
             <a:r>
-              <a:t>→ FIXデザイン通りに組み込めたかが責任範囲</a:t>
-            </a:r>
-          </a:p>
-        </p:txBody>
-      </p:sp>
-      <p:sp>
-        <p:nvSpPr>
-          <p:cNvPr id="26" name="Rectangle 25"/>
+              <a:t>※ デザイン責任は伴いません。BI会社とのやり取りも発生しない想定です。</a:t>
+            </a:r>
+          </a:p>
+        </p:txBody>
+      </p:sp>
+      <p:sp>
+        <p:nvSpPr>
+          <p:cNvPr id="24" name="Rounded Rectangle 23"/>
           <p:cNvSpPr/>
           <p:nvPr/>
         </p:nvSpPr>
         <p:spPr>
           <a:xfrm>
-            <a:off x="5989320" y="1371600"/>
-            <a:ext cx="18288" cy="4389120"/>
-          </a:xfrm>
-          <a:prstGeom prst="rect">
+            <a:off x="6217920" y="3977640"/>
+            <a:ext cx="5394960" cy="1965960"/>
+          </a:xfrm>
+          <a:prstGeom prst="roundRect">
             <a:avLst/>
           </a:prstGeom>
           <a:solidFill>
-            <a:srgbClr val="DDE3EA"/>
+            <a:srgbClr val="FFF8F0"/>
           </a:solidFill>
-          <a:ln>
-            <a:noFill/>
+          <a:ln w="12700">
+            <a:solidFill>
+              <a:srgbClr val="E86C00"/>
+            </a:solidFill>
           </a:ln>
         </p:spPr>
         <p:style>
@@ -4260,7 +4147,165 @@
       </p:sp>
       <p:sp>
         <p:nvSpPr>
+          <p:cNvPr id="25" name="Rectangle 24"/>
+          <p:cNvSpPr/>
+          <p:nvPr/>
+        </p:nvSpPr>
+        <p:spPr>
+          <a:xfrm>
+            <a:off x="6217920" y="3977640"/>
+            <a:ext cx="5394960" cy="411480"/>
+          </a:xfrm>
+          <a:prstGeom prst="rect">
+            <a:avLst/>
+          </a:prstGeom>
+          <a:solidFill>
+            <a:srgbClr val="E86C00"/>
+          </a:solidFill>
+          <a:ln>
+            <a:noFill/>
+          </a:ln>
+        </p:spPr>
+        <p:style>
+          <a:lnRef idx="1">
+            <a:schemeClr val="accent1"/>
+          </a:lnRef>
+          <a:fillRef idx="3">
+            <a:schemeClr val="accent1"/>
+          </a:fillRef>
+          <a:effectRef idx="2">
+            <a:schemeClr val="accent1"/>
+          </a:effectRef>
+          <a:fontRef idx="minor">
+            <a:schemeClr val="lt1"/>
+          </a:fontRef>
+        </p:style>
+        <p:txBody>
+          <a:bodyPr rtlCol="0" anchor="ctr"/>
+          <a:lstStyle/>
+          <a:p>
+            <a:pPr algn="ctr"/>
+          </a:p>
+        </p:txBody>
+      </p:sp>
+      <p:sp>
+        <p:nvSpPr>
+          <p:cNvPr id="26" name="TextBox 25"/>
+          <p:cNvSpPr txBox="1"/>
+          <p:nvPr/>
+        </p:nvSpPr>
+        <p:spPr>
+          <a:xfrm>
+            <a:off x="6400800" y="4032504"/>
+            <a:ext cx="5120640" cy="347472"/>
+          </a:xfrm>
+          <a:prstGeom prst="rect">
+            <a:avLst/>
+          </a:prstGeom>
+          <a:noFill/>
+        </p:spPr>
+        <p:txBody>
+          <a:bodyPr wrap="none">
+            <a:spAutoFit/>
+          </a:bodyPr>
+          <a:lstStyle/>
+          <a:p>
+            <a:pPr>
+              <a:defRPr sz="1150" b="1">
+                <a:solidFill>
+                  <a:srgbClr val="FFFFFF"/>
+                </a:solidFill>
+              </a:defRPr>
+            </a:pPr>
+            <a:r>
+              <a:t>③  デザインコーディング・組み込み</a:t>
+            </a:r>
+          </a:p>
+        </p:txBody>
+      </p:sp>
+      <p:sp>
+        <p:nvSpPr>
           <p:cNvPr id="27" name="TextBox 26"/>
+          <p:cNvSpPr txBox="1"/>
+          <p:nvPr/>
+        </p:nvSpPr>
+        <p:spPr>
+          <a:xfrm>
+            <a:off x="6446520" y="4453128"/>
+            <a:ext cx="5029200" cy="1417320"/>
+          </a:xfrm>
+          <a:prstGeom prst="rect">
+            <a:avLst/>
+          </a:prstGeom>
+          <a:noFill/>
+        </p:spPr>
+        <p:txBody>
+          <a:bodyPr wrap="square">
+            <a:spAutoFit/>
+          </a:bodyPr>
+          <a:lstStyle/>
+          <a:p>
+            <a:pPr>
+              <a:defRPr sz="1000">
+                <a:solidFill>
+                  <a:srgbClr val="555555"/>
+                </a:solidFill>
+              </a:defRPr>
+            </a:pPr>
+            <a:r>
+              <a:t>・②でFIXしたデザインのコーディング</a:t>
+            </a:r>
+          </a:p>
+          <a:p>
+            <a:pPr>
+              <a:spcBef>
+                <a:spcPts val="200"/>
+              </a:spcBef>
+              <a:defRPr sz="1000">
+                <a:solidFill>
+                  <a:srgbClr val="555555"/>
+                </a:solidFill>
+              </a:defRPr>
+            </a:pPr>
+            <a:r>
+              <a:t>・セールスサイトへの組み込み</a:t>
+            </a:r>
+          </a:p>
+          <a:p>
+            <a:pPr>
+              <a:spcBef>
+                <a:spcPts val="600"/>
+              </a:spcBef>
+              <a:defRPr sz="950" b="1">
+                <a:solidFill>
+                  <a:srgbClr val="1A3A5C"/>
+                </a:solidFill>
+              </a:defRPr>
+            </a:pPr>
+            <a:r>
+              <a:t>▶ FIXしたデザインをコーディングし、セールスサイトに埋め込む作業</a:t>
+            </a:r>
+          </a:p>
+          <a:p>
+            <a:pPr>
+              <a:spcBef>
+                <a:spcPts val="400"/>
+              </a:spcBef>
+              <a:defRPr sz="900" i="1">
+                <a:solidFill>
+                  <a:srgbClr val="999999"/>
+                </a:solidFill>
+              </a:defRPr>
+            </a:pPr>
+            <a:r>
+              <a:t>※ FIXデザイン通りに組み込めたかが責任範囲となります。</a:t>
+            </a:r>
+          </a:p>
+        </p:txBody>
+      </p:sp>
+      <p:sp>
+        <p:nvSpPr>
+          <p:cNvPr id="28" name="TextBox 27"/>
           <p:cNvSpPr txBox="1"/>
           <p:nvPr/>
         </p:nvSpPr>

</xml_diff>